<commit_message>
updated silentspire manor layout
</commit_message>
<xml_diff>
--- a/assets/images/adventures/silentspire-manor/interior/layout.pptx
+++ b/assets/images/adventures/silentspire-manor/interior/layout.pptx
@@ -3111,13 +3111,13 @@
           <a:p>
             <a:pPr algn="ctr"/>
             <a:r>
-              <a:rPr lang="ro-RO" sz="1200" dirty="0" smtClean="0">
+              <a:rPr lang="ro-RO" sz="1200" smtClean="0">
                 <a:solidFill>
                   <a:srgbClr val="622E0A"/>
                 </a:solidFill>
                 <a:latin typeface="Libre Baskerville" panose="02000000000000000000" pitchFamily="2" charset="0"/>
               </a:rPr>
-              <a:t>Front Doors</a:t>
+              <a:t>Foyer</a:t>
             </a:r>
             <a:endParaRPr lang="en-US" sz="1200" dirty="0">
               <a:solidFill>
@@ -4116,8 +4116,8 @@
         </p:nvSpPr>
         <p:spPr>
           <a:xfrm>
-            <a:off x="1562100" y="2535810"/>
-            <a:ext cx="50450" cy="1098036"/>
+            <a:off x="1562100" y="2573353"/>
+            <a:ext cx="64604" cy="1060492"/>
           </a:xfrm>
           <a:prstGeom prst="rect">
             <a:avLst/>
@@ -4208,8 +4208,8 @@
         </p:nvSpPr>
         <p:spPr>
           <a:xfrm>
-            <a:off x="1562100" y="244760"/>
-            <a:ext cx="50450" cy="1618178"/>
+            <a:off x="1562100" y="244759"/>
+            <a:ext cx="60786" cy="1949703"/>
           </a:xfrm>
           <a:prstGeom prst="rect">
             <a:avLst/>
@@ -4254,8 +4254,8 @@
         </p:nvSpPr>
         <p:spPr>
           <a:xfrm>
-            <a:off x="1562100" y="1862938"/>
-            <a:ext cx="749300" cy="45719"/>
+            <a:off x="1562100" y="2153023"/>
+            <a:ext cx="480189" cy="45719"/>
           </a:xfrm>
           <a:prstGeom prst="rect">
             <a:avLst/>
@@ -4300,8 +4300,8 @@
         </p:nvSpPr>
         <p:spPr>
           <a:xfrm rot="5400000">
-            <a:off x="895350" y="1168400"/>
-            <a:ext cx="1390650" cy="1390650"/>
+            <a:off x="1181322" y="1751393"/>
+            <a:ext cx="843476" cy="843476"/>
           </a:xfrm>
           <a:prstGeom prst="arc">
             <a:avLst/>
@@ -7146,8 +7146,8 @@
         </p:nvSpPr>
         <p:spPr>
           <a:xfrm>
-            <a:off x="1394232" y="3919206"/>
-            <a:ext cx="2350915" cy="723912"/>
+            <a:off x="1394233" y="3919206"/>
+            <a:ext cx="1885738" cy="723912"/>
           </a:xfrm>
           <a:prstGeom prst="rect">
             <a:avLst/>
@@ -10849,7 +10849,7 @@
           <p:nvPr/>
         </p:nvGrpSpPr>
         <p:grpSpPr>
-          <a:xfrm>
+          <a:xfrm rot="9900000">
             <a:off x="2885213" y="3207137"/>
             <a:ext cx="281090" cy="281090"/>
             <a:chOff x="2836912" y="3174001"/>
@@ -13140,6 +13140,259 @@
           </a:p>
         </p:txBody>
       </p:sp>
+      <p:grpSp>
+        <p:nvGrpSpPr>
+          <p:cNvPr id="263" name="Group 262"/>
+          <p:cNvGrpSpPr/>
+          <p:nvPr/>
+        </p:nvGrpSpPr>
+        <p:grpSpPr>
+          <a:xfrm rot="16200000">
+            <a:off x="1073276" y="1670646"/>
+            <a:ext cx="294854" cy="616305"/>
+            <a:chOff x="2840255" y="1727778"/>
+            <a:chExt cx="375115" cy="784067"/>
+          </a:xfrm>
+        </p:grpSpPr>
+        <p:sp>
+          <p:nvSpPr>
+            <p:cNvPr id="265" name="Rounded Rectangle 264"/>
+            <p:cNvSpPr/>
+            <p:nvPr/>
+          </p:nvSpPr>
+          <p:spPr>
+            <a:xfrm>
+              <a:off x="2840255" y="1727778"/>
+              <a:ext cx="375115" cy="784067"/>
+            </a:xfrm>
+            <a:prstGeom prst="roundRect">
+              <a:avLst/>
+            </a:prstGeom>
+            <a:solidFill>
+              <a:srgbClr val="7E0000"/>
+            </a:solidFill>
+            <a:ln>
+              <a:noFill/>
+            </a:ln>
+          </p:spPr>
+          <p:style>
+            <a:lnRef idx="2">
+              <a:schemeClr val="accent1">
+                <a:shade val="50000"/>
+              </a:schemeClr>
+            </a:lnRef>
+            <a:fillRef idx="1">
+              <a:schemeClr val="accent1"/>
+            </a:fillRef>
+            <a:effectRef idx="0">
+              <a:schemeClr val="accent1"/>
+            </a:effectRef>
+            <a:fontRef idx="minor">
+              <a:schemeClr val="lt1"/>
+            </a:fontRef>
+          </p:style>
+          <p:txBody>
+            <a:bodyPr rtlCol="0" anchor="ctr"/>
+            <a:lstStyle/>
+            <a:p>
+              <a:pPr algn="ctr"/>
+              <a:endParaRPr lang="en-US"/>
+            </a:p>
+          </p:txBody>
+        </p:sp>
+        <p:sp>
+          <p:nvSpPr>
+            <p:cNvPr id="266" name="Rounded Rectangle 265"/>
+            <p:cNvSpPr/>
+            <p:nvPr/>
+          </p:nvSpPr>
+          <p:spPr>
+            <a:xfrm>
+              <a:off x="3005234" y="1790663"/>
+              <a:ext cx="169472" cy="317138"/>
+            </a:xfrm>
+            <a:prstGeom prst="roundRect">
+              <a:avLst/>
+            </a:prstGeom>
+            <a:solidFill>
+              <a:srgbClr val="000000">
+                <a:alpha val="30196"/>
+              </a:srgbClr>
+            </a:solidFill>
+            <a:ln>
+              <a:noFill/>
+            </a:ln>
+          </p:spPr>
+          <p:style>
+            <a:lnRef idx="2">
+              <a:schemeClr val="accent1">
+                <a:shade val="50000"/>
+              </a:schemeClr>
+            </a:lnRef>
+            <a:fillRef idx="1">
+              <a:schemeClr val="accent1"/>
+            </a:fillRef>
+            <a:effectRef idx="0">
+              <a:schemeClr val="accent1"/>
+            </a:effectRef>
+            <a:fontRef idx="minor">
+              <a:schemeClr val="lt1"/>
+            </a:fontRef>
+          </p:style>
+          <p:txBody>
+            <a:bodyPr rtlCol="0" anchor="ctr"/>
+            <a:lstStyle/>
+            <a:p>
+              <a:pPr algn="ctr"/>
+              <a:endParaRPr lang="en-US"/>
+            </a:p>
+          </p:txBody>
+        </p:sp>
+        <p:sp>
+          <p:nvSpPr>
+            <p:cNvPr id="268" name="Rounded Rectangle 267"/>
+            <p:cNvSpPr/>
+            <p:nvPr/>
+          </p:nvSpPr>
+          <p:spPr>
+            <a:xfrm>
+              <a:off x="3005234" y="2126935"/>
+              <a:ext cx="169472" cy="317138"/>
+            </a:xfrm>
+            <a:prstGeom prst="roundRect">
+              <a:avLst/>
+            </a:prstGeom>
+            <a:solidFill>
+              <a:srgbClr val="000000">
+                <a:alpha val="30196"/>
+              </a:srgbClr>
+            </a:solidFill>
+            <a:ln>
+              <a:noFill/>
+            </a:ln>
+          </p:spPr>
+          <p:style>
+            <a:lnRef idx="2">
+              <a:schemeClr val="accent1">
+                <a:shade val="50000"/>
+              </a:schemeClr>
+            </a:lnRef>
+            <a:fillRef idx="1">
+              <a:schemeClr val="accent1"/>
+            </a:fillRef>
+            <a:effectRef idx="0">
+              <a:schemeClr val="accent1"/>
+            </a:effectRef>
+            <a:fontRef idx="minor">
+              <a:schemeClr val="lt1"/>
+            </a:fontRef>
+          </p:style>
+          <p:txBody>
+            <a:bodyPr rtlCol="0" anchor="ctr"/>
+            <a:lstStyle/>
+            <a:p>
+              <a:pPr algn="ctr"/>
+              <a:endParaRPr lang="en-US"/>
+            </a:p>
+          </p:txBody>
+        </p:sp>
+        <p:sp>
+          <p:nvSpPr>
+            <p:cNvPr id="269" name="Rounded Rectangle 268"/>
+            <p:cNvSpPr/>
+            <p:nvPr/>
+          </p:nvSpPr>
+          <p:spPr>
+            <a:xfrm>
+              <a:off x="2876197" y="2455912"/>
+              <a:ext cx="311241" cy="45719"/>
+            </a:xfrm>
+            <a:prstGeom prst="roundRect">
+              <a:avLst/>
+            </a:prstGeom>
+            <a:solidFill>
+              <a:srgbClr val="000000">
+                <a:alpha val="30196"/>
+              </a:srgbClr>
+            </a:solidFill>
+            <a:ln>
+              <a:noFill/>
+            </a:ln>
+          </p:spPr>
+          <p:style>
+            <a:lnRef idx="2">
+              <a:schemeClr val="accent1">
+                <a:shade val="50000"/>
+              </a:schemeClr>
+            </a:lnRef>
+            <a:fillRef idx="1">
+              <a:schemeClr val="accent1"/>
+            </a:fillRef>
+            <a:effectRef idx="0">
+              <a:schemeClr val="accent1"/>
+            </a:effectRef>
+            <a:fontRef idx="minor">
+              <a:schemeClr val="lt1"/>
+            </a:fontRef>
+          </p:style>
+          <p:txBody>
+            <a:bodyPr rtlCol="0" anchor="ctr"/>
+            <a:lstStyle/>
+            <a:p>
+              <a:pPr algn="ctr"/>
+              <a:endParaRPr lang="en-US"/>
+            </a:p>
+          </p:txBody>
+        </p:sp>
+        <p:sp>
+          <p:nvSpPr>
+            <p:cNvPr id="270" name="Rounded Rectangle 269"/>
+            <p:cNvSpPr/>
+            <p:nvPr/>
+          </p:nvSpPr>
+          <p:spPr>
+            <a:xfrm>
+              <a:off x="2869623" y="1736815"/>
+              <a:ext cx="311241" cy="45719"/>
+            </a:xfrm>
+            <a:prstGeom prst="roundRect">
+              <a:avLst/>
+            </a:prstGeom>
+            <a:solidFill>
+              <a:srgbClr val="000000">
+                <a:alpha val="30196"/>
+              </a:srgbClr>
+            </a:solidFill>
+            <a:ln>
+              <a:noFill/>
+            </a:ln>
+          </p:spPr>
+          <p:style>
+            <a:lnRef idx="2">
+              <a:schemeClr val="accent1">
+                <a:shade val="50000"/>
+              </a:schemeClr>
+            </a:lnRef>
+            <a:fillRef idx="1">
+              <a:schemeClr val="accent1"/>
+            </a:fillRef>
+            <a:effectRef idx="0">
+              <a:schemeClr val="accent1"/>
+            </a:effectRef>
+            <a:fontRef idx="minor">
+              <a:schemeClr val="lt1"/>
+            </a:fontRef>
+          </p:style>
+          <p:txBody>
+            <a:bodyPr rtlCol="0" anchor="ctr"/>
+            <a:lstStyle/>
+            <a:p>
+              <a:pPr algn="ctr"/>
+              <a:endParaRPr lang="en-US"/>
+            </a:p>
+          </p:txBody>
+        </p:sp>
+      </p:grpSp>
     </p:spTree>
     <p:extLst>
       <p:ext uri="{BB962C8B-B14F-4D97-AF65-F5344CB8AC3E}">

</xml_diff>